<commit_message>
a bit of shuffling
</commit_message>
<xml_diff>
--- a/slides/6_feature_engineering.pptx
+++ b/slides/6_feature_engineering.pptx
@@ -5,7 +5,7 @@
     <p:sldMasterId id="2147483648" r:id="rId1"/>
   </p:sldMasterIdLst>
   <p:notesMasterIdLst>
-    <p:notesMasterId r:id="rId31"/>
+    <p:notesMasterId r:id="rId30"/>
   </p:notesMasterIdLst>
   <p:sldIdLst>
     <p:sldId id="256" r:id="rId2"/>
@@ -36,7 +36,6 @@
     <p:sldId id="283" r:id="rId27"/>
     <p:sldId id="669" r:id="rId28"/>
     <p:sldId id="284" r:id="rId29"/>
-    <p:sldId id="780" r:id="rId30"/>
   </p:sldIdLst>
   <p:sldSz cx="12192000" cy="6858000"/>
   <p:notesSz cx="6858000" cy="9144000"/>
@@ -507,7 +506,7 @@
           <a:p>
             <a:fld id="{506E0FD1-891F-4B1E-916D-E9B585160BB8}" type="datetimeFigureOut">
               <a:rPr lang="en-GB" smtClean="0"/>
-              <a:t>20/03/2026</a:t>
+              <a:t>09/04/2026</a:t>
             </a:fld>
             <a:endParaRPr lang="en-GB"/>
           </a:p>
@@ -924,7 +923,7 @@
           <a:p>
             <a:fld id="{D68C3F22-27B2-44E3-9C5F-D08126455F6F}" type="datetime1">
               <a:rPr lang="en-GB" smtClean="0"/>
-              <a:t>20/03/2026</a:t>
+              <a:t>09/04/2026</a:t>
             </a:fld>
             <a:endParaRPr lang="en-GB"/>
           </a:p>
@@ -1124,7 +1123,7 @@
           <a:p>
             <a:fld id="{1CD03846-7BF6-4FB6-A921-FF3379ADBD4C}" type="datetime1">
               <a:rPr lang="en-GB" smtClean="0"/>
-              <a:t>20/03/2026</a:t>
+              <a:t>09/04/2026</a:t>
             </a:fld>
             <a:endParaRPr lang="en-GB"/>
           </a:p>
@@ -1334,7 +1333,7 @@
           <a:p>
             <a:fld id="{99E1B91A-3FD0-4144-9C84-63E9688ED2FE}" type="datetime1">
               <a:rPr lang="en-GB" smtClean="0"/>
-              <a:t>20/03/2026</a:t>
+              <a:t>09/04/2026</a:t>
             </a:fld>
             <a:endParaRPr lang="en-GB"/>
           </a:p>
@@ -1534,7 +1533,7 @@
           <a:p>
             <a:fld id="{5295ED7B-FEAD-4734-819F-93EF4B0EA908}" type="datetime1">
               <a:rPr lang="en-GB" smtClean="0"/>
-              <a:t>20/03/2026</a:t>
+              <a:t>09/04/2026</a:t>
             </a:fld>
             <a:endParaRPr lang="en-GB"/>
           </a:p>
@@ -1810,7 +1809,7 @@
           <a:p>
             <a:fld id="{D2D5D4B4-C926-4B45-8815-1ED8911179A2}" type="datetime1">
               <a:rPr lang="en-GB" smtClean="0"/>
-              <a:t>20/03/2026</a:t>
+              <a:t>09/04/2026</a:t>
             </a:fld>
             <a:endParaRPr lang="en-GB"/>
           </a:p>
@@ -2078,7 +2077,7 @@
           <a:p>
             <a:fld id="{B4C5210A-0E37-4935-93AF-69F21A5F712F}" type="datetime1">
               <a:rPr lang="en-GB" smtClean="0"/>
-              <a:t>20/03/2026</a:t>
+              <a:t>09/04/2026</a:t>
             </a:fld>
             <a:endParaRPr lang="en-GB"/>
           </a:p>
@@ -2493,7 +2492,7 @@
           <a:p>
             <a:fld id="{3D3A6B2F-436C-4691-80E8-9C890E000E9D}" type="datetime1">
               <a:rPr lang="en-GB" smtClean="0"/>
-              <a:t>20/03/2026</a:t>
+              <a:t>09/04/2026</a:t>
             </a:fld>
             <a:endParaRPr lang="en-GB"/>
           </a:p>
@@ -2635,7 +2634,7 @@
           <a:p>
             <a:fld id="{84385F4C-D74B-496F-8D21-97E3549C783B}" type="datetime1">
               <a:rPr lang="en-GB" smtClean="0"/>
-              <a:t>20/03/2026</a:t>
+              <a:t>09/04/2026</a:t>
             </a:fld>
             <a:endParaRPr lang="en-GB"/>
           </a:p>
@@ -2748,7 +2747,7 @@
           <a:p>
             <a:fld id="{0CBDCB32-C241-4703-A832-4EB47BD54E83}" type="datetime1">
               <a:rPr lang="en-GB" smtClean="0"/>
-              <a:t>20/03/2026</a:t>
+              <a:t>09/04/2026</a:t>
             </a:fld>
             <a:endParaRPr lang="en-GB"/>
           </a:p>
@@ -3061,7 +3060,7 @@
           <a:p>
             <a:fld id="{85C150FF-BE95-4D25-A16A-E368A81CBF24}" type="datetime1">
               <a:rPr lang="en-GB" smtClean="0"/>
-              <a:t>20/03/2026</a:t>
+              <a:t>09/04/2026</a:t>
             </a:fld>
             <a:endParaRPr lang="en-GB"/>
           </a:p>
@@ -3350,7 +3349,7 @@
           <a:p>
             <a:fld id="{F3C5DB4B-B349-43C9-A424-BADA723AD9F1}" type="datetime1">
               <a:rPr lang="en-GB" smtClean="0"/>
-              <a:t>20/03/2026</a:t>
+              <a:t>09/04/2026</a:t>
             </a:fld>
             <a:endParaRPr lang="en-GB"/>
           </a:p>
@@ -3593,7 +3592,7 @@
           <a:p>
             <a:fld id="{12632426-0A0C-405F-A3D0-2D11AA44702A}" type="datetime1">
               <a:rPr lang="en-GB" smtClean="0"/>
-              <a:t>20/03/2026</a:t>
+              <a:t>09/04/2026</a:t>
             </a:fld>
             <a:endParaRPr lang="en-GB"/>
           </a:p>
@@ -8846,143 +8845,6 @@
     <p:extLst>
       <p:ext uri="{BB962C8B-B14F-4D97-AF65-F5344CB8AC3E}">
         <p14:creationId xmlns:p14="http://schemas.microsoft.com/office/powerpoint/2010/main" val="975400455"/>
-      </p:ext>
-    </p:extLst>
-  </p:cSld>
-  <p:clrMapOvr>
-    <a:masterClrMapping/>
-  </p:clrMapOvr>
-</p:sld>
-</file>
-
-<file path=ppt/slides/slide29.xml><?xml version="1.0" encoding="utf-8"?>
-<p:sld xmlns:a="http://schemas.openxmlformats.org/drawingml/2006/main" xmlns:r="http://schemas.openxmlformats.org/officeDocument/2006/relationships" xmlns:p="http://schemas.openxmlformats.org/presentationml/2006/main">
-  <p:cSld>
-    <p:spTree>
-      <p:nvGrpSpPr>
-        <p:cNvPr id="1" name=""/>
-        <p:cNvGrpSpPr/>
-        <p:nvPr/>
-      </p:nvGrpSpPr>
-      <p:grpSpPr>
-        <a:xfrm>
-          <a:off x="0" y="0"/>
-          <a:ext cx="0" cy="0"/>
-          <a:chOff x="0" y="0"/>
-          <a:chExt cx="0" cy="0"/>
-        </a:xfrm>
-      </p:grpSpPr>
-      <p:sp>
-        <p:nvSpPr>
-          <p:cNvPr id="3" name="Titel 2">
-            <a:extLst>
-              <a:ext uri="{FF2B5EF4-FFF2-40B4-BE49-F238E27FC236}">
-                <a16:creationId xmlns:a16="http://schemas.microsoft.com/office/drawing/2014/main" id="{67675B1F-E173-98A4-AD50-0B743B2D6DA1}"/>
-              </a:ext>
-            </a:extLst>
-          </p:cNvPr>
-          <p:cNvSpPr>
-            <a:spLocks noGrp="1"/>
-          </p:cNvSpPr>
-          <p:nvPr>
-            <p:ph type="title"/>
-          </p:nvPr>
-        </p:nvSpPr>
-        <p:spPr/>
-        <p:txBody>
-          <a:bodyPr/>
-          <a:lstStyle/>
-          <a:p>
-            <a:r>
-              <a:rPr lang="de-DE" dirty="0"/>
-              <a:t>Practice Project</a:t>
-            </a:r>
-          </a:p>
-        </p:txBody>
-      </p:sp>
-      <p:sp>
-        <p:nvSpPr>
-          <p:cNvPr id="4" name="Inhaltsplatzhalter 3">
-            <a:extLst>
-              <a:ext uri="{FF2B5EF4-FFF2-40B4-BE49-F238E27FC236}">
-                <a16:creationId xmlns:a16="http://schemas.microsoft.com/office/drawing/2014/main" id="{44DD3C46-343C-0713-2B34-80AA5550422A}"/>
-              </a:ext>
-            </a:extLst>
-          </p:cNvPr>
-          <p:cNvSpPr>
-            <a:spLocks noGrp="1"/>
-          </p:cNvSpPr>
-          <p:nvPr>
-            <p:ph idx="1"/>
-          </p:nvPr>
-        </p:nvSpPr>
-        <p:spPr/>
-        <p:txBody>
-          <a:bodyPr/>
-          <a:lstStyle/>
-          <a:p>
-            <a:pPr marL="0" indent="0">
-              <a:buNone/>
-            </a:pPr>
-            <a:endParaRPr lang="de-DE" dirty="0">
-              <a:hlinkClick r:id="rId2"/>
-            </a:endParaRPr>
-          </a:p>
-          <a:p>
-            <a:pPr marL="0" indent="0">
-              <a:buNone/>
-            </a:pPr>
-            <a:endParaRPr lang="de-DE" dirty="0">
-              <a:hlinkClick r:id="rId2"/>
-            </a:endParaRPr>
-          </a:p>
-          <a:p>
-            <a:pPr marL="0" indent="0">
-              <a:buNone/>
-            </a:pPr>
-            <a:r>
-              <a:rPr lang="de-DE" dirty="0">
-                <a:hlinkClick r:id="rId2"/>
-              </a:rPr>
-              <a:t>Kaggle competition: Spaceship Titanic</a:t>
-            </a:r>
-            <a:endParaRPr lang="de-DE" dirty="0"/>
-          </a:p>
-        </p:txBody>
-      </p:sp>
-      <p:sp>
-        <p:nvSpPr>
-          <p:cNvPr id="2" name="Foliennummernplatzhalter 1">
-            <a:extLst>
-              <a:ext uri="{FF2B5EF4-FFF2-40B4-BE49-F238E27FC236}">
-                <a16:creationId xmlns:a16="http://schemas.microsoft.com/office/drawing/2014/main" id="{4AD244A2-3D2F-65EC-08C2-585F58E4A017}"/>
-              </a:ext>
-            </a:extLst>
-          </p:cNvPr>
-          <p:cNvSpPr>
-            <a:spLocks noGrp="1"/>
-          </p:cNvSpPr>
-          <p:nvPr>
-            <p:ph type="sldNum" sz="quarter" idx="12"/>
-          </p:nvPr>
-        </p:nvSpPr>
-        <p:spPr/>
-        <p:txBody>
-          <a:bodyPr/>
-          <a:lstStyle/>
-          <a:p>
-            <a:fld id="{3D4C94FE-FF23-4504-88E9-14D481113291}" type="slidenum">
-              <a:rPr lang="en-GB" smtClean="0"/>
-              <a:t>29</a:t>
-            </a:fld>
-            <a:endParaRPr lang="en-GB"/>
-          </a:p>
-        </p:txBody>
-      </p:sp>
-    </p:spTree>
-    <p:extLst>
-      <p:ext uri="{BB962C8B-B14F-4D97-AF65-F5344CB8AC3E}">
-        <p14:creationId xmlns:p14="http://schemas.microsoft.com/office/powerpoint/2010/main" val="2139412117"/>
       </p:ext>
     </p:extLst>
   </p:cSld>

</xml_diff>